<commit_message>
chore(notes): auto sync 2026/07/21 周二
</commit_message>
<xml_diff>
--- a/Uni Freiburg/能量收集/PROJECT/System_Operation_Flowchart_simple.pptx
+++ b/Uni Freiburg/能量收集/PROJECT/System_Operation_Flowchart_simple.pptx
@@ -2,13 +2,13 @@
 <file path=ppt/presentation.xml><?xml version="1.0" encoding="utf-8"?>
 <p:presentation xmlns:p="http://schemas.openxmlformats.org/presentationml/2006/main">
   <p:sldMasterIdLst>
-    <p:sldMasterId xmlns:r="http://schemas.openxmlformats.org/officeDocument/2006/relationships" id="2147483648" r:id="R0259461a285244ea"/>
+    <p:sldMasterId xmlns:r="http://schemas.openxmlformats.org/officeDocument/2006/relationships" id="2147483648" r:id="R80159c4563fe4f8a"/>
   </p:sldMasterIdLst>
   <p:notesMasterIdLst>
-    <p:notesMasterId xmlns:r="http://schemas.openxmlformats.org/officeDocument/2006/relationships" r:id="R3906a279f33048e4"/>
+    <p:notesMasterId xmlns:r="http://schemas.openxmlformats.org/officeDocument/2006/relationships" r:id="R65bf8e71ab7840ed"/>
   </p:notesMasterIdLst>
   <p:sldIdLst>
-    <p:sldId xmlns:r="http://schemas.openxmlformats.org/officeDocument/2006/relationships" id="256" r:id="R36ff66e76b6f4566"/>
+    <p:sldId xmlns:r="http://schemas.openxmlformats.org/officeDocument/2006/relationships" id="256" r:id="Raec2938b6d954620"/>
   </p:sldIdLst>
   <p:sldSz cx="12192000" cy="6858000"/>
   <p:notesSz cx="6858000" cy="9144000"/>
@@ -601,7 +601,7 @@
   </p:cSld>
   <p:clrMap bg1="lt1" tx1="dk1" bg2="lt2" tx2="dk2" accent1="accent1" accent2="accent2" accent3="accent3" accent4="accent4" accent5="accent5" accent6="accent6" hlink="hlink" folHlink="folHlink"/>
   <p:sldLayoutIdLst>
-    <p:sldLayoutId xmlns:r="http://schemas.openxmlformats.org/officeDocument/2006/relationships" id="2147483649" r:id="R56b614102de94518"/>
+    <p:sldLayoutId xmlns:r="http://schemas.openxmlformats.org/officeDocument/2006/relationships" id="2147483649" r:id="Rff6da6d525304a63"/>
   </p:sldLayoutIdLst>
   <p:txStyles>
     <p:titleStyle>
@@ -1149,10 +1149,10 @@
       </p:grpSpPr>
       <p:sp>
         <p:nvSpPr>
-          <p:cNvPr id="31" name="left-rail">
+          <p:cNvPr id="35" name="left-rail">
             <a:extLst xmlns:a="http://schemas.openxmlformats.org/drawingml/2006/main">
               <a:ext uri="{FF2B5EF4-FFF2-40B4-BE49-F238E27FC236}">
-                <a16:creationId xmlns:a16="http://schemas.microsoft.com/office/drawing/2014/main" id="{8FE8A13E-8D60-4515-89EE-DEF5ABB9052D}"/>
+                <a16:creationId xmlns:a16="http://schemas.microsoft.com/office/drawing/2014/main" id="{02FDDBA8-A258-452D-B746-C58BD32FAD05}"/>
               </a:ext>
             </a:extLst>
           </p:cNvPr>
@@ -1183,7 +1183,7 @@
           <p:cNvPr id="2" name="left-rule">
             <a:extLst xmlns:a="http://schemas.openxmlformats.org/drawingml/2006/main">
               <a:ext uri="{FF2B5EF4-FFF2-40B4-BE49-F238E27FC236}">
-                <a16:creationId xmlns:a16="http://schemas.microsoft.com/office/drawing/2014/main" id="{413E9DB4-D74E-46A9-ACF8-77008903D7F3}"/>
+                <a16:creationId xmlns:a16="http://schemas.microsoft.com/office/drawing/2014/main" id="{37FA5628-BD0F-4079-905A-0395387C3F0E}"/>
               </a:ext>
             </a:extLst>
           </p:cNvPr>
@@ -1214,7 +1214,7 @@
           <p:cNvPr id="3" name="footer-rule">
             <a:extLst xmlns:a="http://schemas.openxmlformats.org/drawingml/2006/main">
               <a:ext uri="{FF2B5EF4-FFF2-40B4-BE49-F238E27FC236}">
-                <a16:creationId xmlns:a16="http://schemas.microsoft.com/office/drawing/2014/main" id="{E37387AF-111B-4E01-9D7A-DBA1DF2F6ECB}"/>
+                <a16:creationId xmlns:a16="http://schemas.microsoft.com/office/drawing/2014/main" id="{220A0502-1650-4BDF-A643-65EBA41AFC1E}"/>
               </a:ext>
             </a:extLst>
           </p:cNvPr>
@@ -1245,7 +1245,7 @@
           <p:cNvPr id="4" name="title">
             <a:extLst xmlns:a="http://schemas.openxmlformats.org/drawingml/2006/main">
               <a:ext uri="{FF2B5EF4-FFF2-40B4-BE49-F238E27FC236}">
-                <a16:creationId xmlns:a16="http://schemas.microsoft.com/office/drawing/2014/main" id="{21BD974B-EEEB-49CD-B750-81CD2C5361AC}"/>
+                <a16:creationId xmlns:a16="http://schemas.microsoft.com/office/drawing/2014/main" id="{757D3E2F-D5B7-47D7-A56C-137596DE9526}"/>
               </a:ext>
             </a:extLst>
           </p:cNvPr>
@@ -1295,7 +1295,7 @@
           <p:cNvPr id="5" name="title-rule">
             <a:extLst xmlns:a="http://schemas.openxmlformats.org/drawingml/2006/main">
               <a:ext uri="{FF2B5EF4-FFF2-40B4-BE49-F238E27FC236}">
-                <a16:creationId xmlns:a16="http://schemas.microsoft.com/office/drawing/2014/main" id="{38B4B8E8-E78A-4808-AB7E-82CB07EDC020}"/>
+                <a16:creationId xmlns:a16="http://schemas.microsoft.com/office/drawing/2014/main" id="{82FA3E71-DE51-4543-8F2F-5C86060109EE}"/>
               </a:ext>
             </a:extLst>
           </p:cNvPr>
@@ -1326,7 +1326,7 @@
           <p:cNvPr id="6" name="subtitle">
             <a:extLst xmlns:a="http://schemas.openxmlformats.org/drawingml/2006/main">
               <a:ext uri="{FF2B5EF4-FFF2-40B4-BE49-F238E27FC236}">
-                <a16:creationId xmlns:a16="http://schemas.microsoft.com/office/drawing/2014/main" id="{8C8720B7-8A3A-4FF1-9197-B08E866AC957}"/>
+                <a16:creationId xmlns:a16="http://schemas.microsoft.com/office/drawing/2014/main" id="{861D675D-28EE-47A2-8F5E-F2B10F3F57D0}"/>
               </a:ext>
             </a:extLst>
           </p:cNvPr>
@@ -1376,7 +1376,7 @@
           <p:cNvPr id="7" name="continuous-label">
             <a:extLst xmlns:a="http://schemas.openxmlformats.org/drawingml/2006/main">
               <a:ext uri="{FF2B5EF4-FFF2-40B4-BE49-F238E27FC236}">
-                <a16:creationId xmlns:a16="http://schemas.microsoft.com/office/drawing/2014/main" id="{21A469E2-9659-4493-B2F0-278F8FDE513E}"/>
+                <a16:creationId xmlns:a16="http://schemas.microsoft.com/office/drawing/2014/main" id="{28B4EA42-25C0-4710-8D83-1AA7AAD18427}"/>
               </a:ext>
             </a:extLst>
           </p:cNvPr>
@@ -1387,8 +1387,8 @@
         </p:nvSpPr>
         <p:spPr>
           <a:xfrm xmlns:a="http://schemas.openxmlformats.org/drawingml/2006/main">
-            <a:off x="1000125" y="1428750"/>
-            <a:ext cx="1238250" cy="228600"/>
+            <a:off x="876300" y="1428750"/>
+            <a:ext cx="5429250" cy="228600"/>
           </a:xfrm>
           <a:prstGeom xmlns:a="http://schemas.openxmlformats.org/drawingml/2006/main" prst="rect">
             <a:avLst/>
@@ -1416,7 +1416,7 @@
                   <a:srgbClr val="548235"/>
                 </a:solidFill>
               </a:rPr>
-              <a:t>CONTINUOUS</a:t>
+              <a:t>CONTINUOUS ENERGY PATH</a:t>
             </a:r>
           </a:p>
         </p:txBody>
@@ -1426,7 +1426,7 @@
           <p:cNvPr id="8" name="minute-label">
             <a:extLst xmlns:a="http://schemas.openxmlformats.org/drawingml/2006/main">
               <a:ext uri="{FF2B5EF4-FFF2-40B4-BE49-F238E27FC236}">
-                <a16:creationId xmlns:a16="http://schemas.microsoft.com/office/drawing/2014/main" id="{AAD9CFC3-5040-47C7-948F-4A2710D4BA8F}"/>
+                <a16:creationId xmlns:a16="http://schemas.microsoft.com/office/drawing/2014/main" id="{560BEA5F-D7AC-462F-A38F-C597F8DB77B4}"/>
               </a:ext>
             </a:extLst>
           </p:cNvPr>
@@ -1437,8 +1437,8 @@
         </p:nvSpPr>
         <p:spPr>
           <a:xfrm xmlns:a="http://schemas.openxmlformats.org/drawingml/2006/main">
-            <a:off x="5095875" y="1428750"/>
-            <a:ext cx="3333750" cy="228600"/>
+            <a:off x="6429375" y="1428750"/>
+            <a:ext cx="4524375" cy="228600"/>
           </a:xfrm>
           <a:prstGeom xmlns:a="http://schemas.openxmlformats.org/drawingml/2006/main" prst="rect">
             <a:avLst/>
@@ -1476,7 +1476,7 @@
           <p:cNvPr id="9" name="harvest">
             <a:extLst xmlns:a="http://schemas.openxmlformats.org/drawingml/2006/main">
               <a:ext uri="{FF2B5EF4-FFF2-40B4-BE49-F238E27FC236}">
-                <a16:creationId xmlns:a16="http://schemas.microsoft.com/office/drawing/2014/main" id="{C1AA40AE-372D-47F3-919F-528CEBF2341C}"/>
+                <a16:creationId xmlns:a16="http://schemas.microsoft.com/office/drawing/2014/main" id="{E5E1554A-BCF1-445D-A26F-461919331629}"/>
               </a:ext>
             </a:extLst>
           </p:cNvPr>
@@ -1487,12 +1487,12 @@
         </p:nvSpPr>
         <p:spPr>
           <a:xfrm xmlns:a="http://schemas.openxmlformats.org/drawingml/2006/main">
-            <a:off x="742950" y="1905000"/>
-            <a:ext cx="1619250" cy="685800"/>
+            <a:off x="647700" y="1905000"/>
+            <a:ext cx="1333500" cy="742950"/>
           </a:xfrm>
           <a:prstGeom xmlns:a="http://schemas.openxmlformats.org/drawingml/2006/main" prst="roundRect">
             <a:avLst>
-              <a:gd name="adj" fmla="val 8333"/>
+              <a:gd name="adj" fmla="val 7692"/>
             </a:avLst>
           </a:prstGeom>
           <a:solidFill xmlns:a="http://schemas.openxmlformats.org/drawingml/2006/main">
@@ -1510,46 +1510,46 @@
           <a:lstStyle xmlns:a="http://schemas.openxmlformats.org/drawingml/2006/main"/>
           <a:p xmlns:a="http://schemas.openxmlformats.org/drawingml/2006/main">
             <a:pPr algn="ctr">
-              <a:defRPr sz="1050" b="1">
+              <a:defRPr sz="900" b="1">
                 <a:solidFill>
                   <a:srgbClr val="111111"/>
                 </a:solidFill>
               </a:defRPr>
             </a:pPr>
             <a:r>
-              <a:rPr sz="1050" b="1">
+              <a:rPr sz="900" b="1">
                 <a:solidFill>
                   <a:srgbClr val="111111"/>
                 </a:solidFill>
               </a:rPr>
-              <a:t>TEG + LTC3108-1</a:t>
+              <a:t>TEG Array</a:t>
             </a:r>
           </a:p>
           <a:p xmlns:a="http://schemas.openxmlformats.org/drawingml/2006/main">
             <a:pPr algn="ctr">
-              <a:defRPr sz="1050" b="1">
+              <a:defRPr sz="900" b="1">
                 <a:solidFill>
                   <a:srgbClr val="111111"/>
                 </a:solidFill>
               </a:defRPr>
             </a:pPr>
             <a:r>
-              <a:rPr sz="1050" b="1">
+              <a:rPr sz="900" b="1">
                 <a:solidFill>
                   <a:srgbClr val="111111"/>
                 </a:solidFill>
               </a:rPr>
-              <a:t>Harvest Energy</a:t>
+              <a:t>5 x 1MD06-097-05</a:t>
             </a:r>
           </a:p>
         </p:txBody>
       </p:sp>
       <p:sp>
         <p:nvSpPr>
-          <p:cNvPr id="10" name="storage">
+          <p:cNvPr id="10" name="boost">
             <a:extLst xmlns:a="http://schemas.openxmlformats.org/drawingml/2006/main">
               <a:ext uri="{FF2B5EF4-FFF2-40B4-BE49-F238E27FC236}">
-                <a16:creationId xmlns:a16="http://schemas.microsoft.com/office/drawing/2014/main" id="{652A75B7-03AF-479A-9B34-A7BA2D51D19E}"/>
+                <a16:creationId xmlns:a16="http://schemas.microsoft.com/office/drawing/2014/main" id="{D55DB8BD-7F13-4E88-8A74-6D379E02B61B}"/>
               </a:ext>
             </a:extLst>
           </p:cNvPr>
@@ -1560,12 +1560,12 @@
         </p:nvSpPr>
         <p:spPr>
           <a:xfrm xmlns:a="http://schemas.openxmlformats.org/drawingml/2006/main">
-            <a:off x="2762250" y="1905000"/>
-            <a:ext cx="1619250" cy="685800"/>
+            <a:off x="2152650" y="1905000"/>
+            <a:ext cx="1333500" cy="742950"/>
           </a:xfrm>
           <a:prstGeom xmlns:a="http://schemas.openxmlformats.org/drawingml/2006/main" prst="roundRect">
             <a:avLst>
-              <a:gd name="adj" fmla="val 8333"/>
+              <a:gd name="adj" fmla="val 7692"/>
             </a:avLst>
           </a:prstGeom>
           <a:solidFill xmlns:a="http://schemas.openxmlformats.org/drawingml/2006/main">
@@ -1583,46 +1583,46 @@
           <a:lstStyle xmlns:a="http://schemas.openxmlformats.org/drawingml/2006/main"/>
           <a:p xmlns:a="http://schemas.openxmlformats.org/drawingml/2006/main">
             <a:pPr algn="ctr">
-              <a:defRPr sz="1125" b="1">
+              <a:defRPr sz="975" b="1">
                 <a:solidFill>
                   <a:srgbClr val="111111"/>
                 </a:solidFill>
               </a:defRPr>
             </a:pPr>
             <a:r>
-              <a:rPr sz="1125" b="1">
+              <a:rPr sz="975" b="1">
                 <a:solidFill>
                   <a:srgbClr val="111111"/>
                 </a:solidFill>
               </a:rPr>
-              <a:t>Charge</a:t>
+              <a:t>Boost Converter</a:t>
             </a:r>
           </a:p>
           <a:p xmlns:a="http://schemas.openxmlformats.org/drawingml/2006/main">
             <a:pPr algn="ctr">
-              <a:defRPr sz="1125" b="1">
+              <a:defRPr sz="975" b="1">
                 <a:solidFill>
                   <a:srgbClr val="111111"/>
                 </a:solidFill>
               </a:defRPr>
             </a:pPr>
             <a:r>
-              <a:rPr sz="1125" b="1">
+              <a:rPr sz="975" b="1">
                 <a:solidFill>
                   <a:srgbClr val="111111"/>
                 </a:solidFill>
               </a:rPr>
-              <a:t>Supercapacitor</a:t>
+              <a:t>LTC3108-1</a:t>
             </a:r>
           </a:p>
         </p:txBody>
       </p:sp>
       <p:sp>
         <p:nvSpPr>
-          <p:cNvPr id="11" name="wake">
+          <p:cNvPr id="11" name="storage">
             <a:extLst xmlns:a="http://schemas.openxmlformats.org/drawingml/2006/main">
               <a:ext uri="{FF2B5EF4-FFF2-40B4-BE49-F238E27FC236}">
-                <a16:creationId xmlns:a16="http://schemas.microsoft.com/office/drawing/2014/main" id="{5AB5CEC4-E505-47A9-9724-4CC75E1CB3F1}"/>
+                <a16:creationId xmlns:a16="http://schemas.microsoft.com/office/drawing/2014/main" id="{0CFE179D-C9C2-412A-977E-27F9144156D4}"/>
               </a:ext>
             </a:extLst>
           </p:cNvPr>
@@ -1633,20 +1633,20 @@
         </p:nvSpPr>
         <p:spPr>
           <a:xfrm xmlns:a="http://schemas.openxmlformats.org/drawingml/2006/main">
-            <a:off x="4781550" y="1905000"/>
-            <a:ext cx="1619250" cy="685800"/>
+            <a:off x="3657600" y="1905000"/>
+            <a:ext cx="1333500" cy="742950"/>
           </a:xfrm>
           <a:prstGeom xmlns:a="http://schemas.openxmlformats.org/drawingml/2006/main" prst="roundRect">
             <a:avLst>
-              <a:gd name="adj" fmla="val 8333"/>
+              <a:gd name="adj" fmla="val 7692"/>
             </a:avLst>
           </a:prstGeom>
           <a:solidFill xmlns:a="http://schemas.openxmlformats.org/drawingml/2006/main">
-            <a:srgbClr val="D9EAF7"/>
+            <a:srgbClr val="E2F0D9"/>
           </a:solidFill>
           <a:ln xmlns:a="http://schemas.openxmlformats.org/drawingml/2006/main" w="14288">
             <a:solidFill>
-              <a:srgbClr val="2F5597"/>
+              <a:srgbClr val="548235"/>
             </a:solidFill>
             <a:prstDash val="solid"/>
           </a:ln>
@@ -1656,14 +1656,160 @@
           <a:lstStyle xmlns:a="http://schemas.openxmlformats.org/drawingml/2006/main"/>
           <a:p xmlns:a="http://schemas.openxmlformats.org/drawingml/2006/main">
             <a:pPr algn="ctr">
-              <a:defRPr sz="1125" b="1">
+              <a:defRPr sz="900" b="1">
                 <a:solidFill>
                   <a:srgbClr val="111111"/>
                 </a:solidFill>
               </a:defRPr>
             </a:pPr>
             <a:r>
-              <a:rPr sz="1125" b="1">
+              <a:rPr sz="900" b="1">
+                <a:solidFill>
+                  <a:srgbClr val="111111"/>
+                </a:solidFill>
+              </a:rPr>
+              <a:t>Energy Storage</a:t>
+            </a:r>
+          </a:p>
+          <a:p xmlns:a="http://schemas.openxmlformats.org/drawingml/2006/main">
+            <a:pPr algn="ctr">
+              <a:defRPr sz="900" b="1">
+                <a:solidFill>
+                  <a:srgbClr val="111111"/>
+                </a:solidFill>
+              </a:defRPr>
+            </a:pPr>
+            <a:r>
+              <a:rPr sz="900" b="1">
+                <a:solidFill>
+                  <a:srgbClr val="111111"/>
+                </a:solidFill>
+              </a:rPr>
+              <a:t>0.22 F Supercapacitor</a:t>
+            </a:r>
+          </a:p>
+        </p:txBody>
+      </p:sp>
+      <p:sp>
+        <p:nvSpPr>
+          <p:cNvPr id="12" name="buck">
+            <a:extLst xmlns:a="http://schemas.openxmlformats.org/drawingml/2006/main">
+              <a:ext uri="{FF2B5EF4-FFF2-40B4-BE49-F238E27FC236}">
+                <a16:creationId xmlns:a16="http://schemas.microsoft.com/office/drawing/2014/main" id="{C19D6498-627D-46E5-9CD9-F488FD5D2E43}"/>
+              </a:ext>
+            </a:extLst>
+          </p:cNvPr>
+          <p:cNvSpPr>
+            <a:spLocks xmlns:a="http://schemas.openxmlformats.org/drawingml/2006/main" noGrp="1"/>
+          </p:cNvSpPr>
+          <p:nvPr/>
+        </p:nvSpPr>
+        <p:spPr>
+          <a:xfrm xmlns:a="http://schemas.openxmlformats.org/drawingml/2006/main">
+            <a:off x="5162550" y="1905000"/>
+            <a:ext cx="1333500" cy="742950"/>
+          </a:xfrm>
+          <a:prstGeom xmlns:a="http://schemas.openxmlformats.org/drawingml/2006/main" prst="roundRect">
+            <a:avLst>
+              <a:gd name="adj" fmla="val 7692"/>
+            </a:avLst>
+          </a:prstGeom>
+          <a:solidFill xmlns:a="http://schemas.openxmlformats.org/drawingml/2006/main">
+            <a:srgbClr val="E2F0D9"/>
+          </a:solidFill>
+          <a:ln xmlns:a="http://schemas.openxmlformats.org/drawingml/2006/main" w="14288">
+            <a:solidFill>
+              <a:srgbClr val="548235"/>
+            </a:solidFill>
+            <a:prstDash val="solid"/>
+          </a:ln>
+        </p:spPr>
+        <p:txBody>
+          <a:bodyPr xmlns:a="http://schemas.openxmlformats.org/drawingml/2006/main" anchor="ctr"/>
+          <a:lstStyle xmlns:a="http://schemas.openxmlformats.org/drawingml/2006/main"/>
+          <a:p xmlns:a="http://schemas.openxmlformats.org/drawingml/2006/main">
+            <a:pPr algn="ctr">
+              <a:defRPr sz="900" b="1">
+                <a:solidFill>
+                  <a:srgbClr val="111111"/>
+                </a:solidFill>
+              </a:defRPr>
+            </a:pPr>
+            <a:r>
+              <a:rPr sz="900" b="1">
+                <a:solidFill>
+                  <a:srgbClr val="111111"/>
+                </a:solidFill>
+              </a:rPr>
+              <a:t>Buck Converter</a:t>
+            </a:r>
+          </a:p>
+          <a:p xmlns:a="http://schemas.openxmlformats.org/drawingml/2006/main">
+            <a:pPr algn="ctr">
+              <a:defRPr sz="900" b="1">
+                <a:solidFill>
+                  <a:srgbClr val="111111"/>
+                </a:solidFill>
+              </a:defRPr>
+            </a:pPr>
+            <a:r>
+              <a:rPr sz="900" b="1">
+                <a:solidFill>
+                  <a:srgbClr val="111111"/>
+                </a:solidFill>
+              </a:rPr>
+              <a:t>Regulated System Supply</a:t>
+            </a:r>
+          </a:p>
+        </p:txBody>
+      </p:sp>
+      <p:sp>
+        <p:nvSpPr>
+          <p:cNvPr id="13" name="wake">
+            <a:extLst xmlns:a="http://schemas.openxmlformats.org/drawingml/2006/main">
+              <a:ext uri="{FF2B5EF4-FFF2-40B4-BE49-F238E27FC236}">
+                <a16:creationId xmlns:a16="http://schemas.microsoft.com/office/drawing/2014/main" id="{49F83520-F09F-4065-94BC-6413664E7338}"/>
+              </a:ext>
+            </a:extLst>
+          </p:cNvPr>
+          <p:cNvSpPr>
+            <a:spLocks xmlns:a="http://schemas.openxmlformats.org/drawingml/2006/main" noGrp="1"/>
+          </p:cNvSpPr>
+          <p:nvPr/>
+        </p:nvSpPr>
+        <p:spPr>
+          <a:xfrm xmlns:a="http://schemas.openxmlformats.org/drawingml/2006/main">
+            <a:off x="6667500" y="1905000"/>
+            <a:ext cx="1333500" cy="742950"/>
+          </a:xfrm>
+          <a:prstGeom xmlns:a="http://schemas.openxmlformats.org/drawingml/2006/main" prst="roundRect">
+            <a:avLst>
+              <a:gd name="adj" fmla="val 7692"/>
+            </a:avLst>
+          </a:prstGeom>
+          <a:solidFill xmlns:a="http://schemas.openxmlformats.org/drawingml/2006/main">
+            <a:srgbClr val="D9EAF7"/>
+          </a:solidFill>
+          <a:ln xmlns:a="http://schemas.openxmlformats.org/drawingml/2006/main" w="14288">
+            <a:solidFill>
+              <a:srgbClr val="2F5597"/>
+            </a:solidFill>
+            <a:prstDash val="solid"/>
+          </a:ln>
+        </p:spPr>
+        <p:txBody>
+          <a:bodyPr xmlns:a="http://schemas.openxmlformats.org/drawingml/2006/main" anchor="ctr"/>
+          <a:lstStyle xmlns:a="http://schemas.openxmlformats.org/drawingml/2006/main"/>
+          <a:p xmlns:a="http://schemas.openxmlformats.org/drawingml/2006/main">
+            <a:pPr algn="ctr">
+              <a:defRPr sz="975" b="1">
+                <a:solidFill>
+                  <a:srgbClr val="111111"/>
+                </a:solidFill>
+              </a:defRPr>
+            </a:pPr>
+            <a:r>
+              <a:rPr sz="975" b="1">
                 <a:solidFill>
                   <a:srgbClr val="111111"/>
                 </a:solidFill>
@@ -1673,14 +1819,14 @@
           </a:p>
           <a:p xmlns:a="http://schemas.openxmlformats.org/drawingml/2006/main">
             <a:pPr algn="ctr">
-              <a:defRPr sz="1125" b="1">
+              <a:defRPr sz="975" b="1">
                 <a:solidFill>
                   <a:srgbClr val="111111"/>
                 </a:solidFill>
               </a:defRPr>
             </a:pPr>
             <a:r>
-              <a:rPr sz="1125" b="1">
+              <a:rPr sz="975" b="1">
                 <a:solidFill>
                   <a:srgbClr val="111111"/>
                 </a:solidFill>
@@ -1692,10 +1838,10 @@
       </p:sp>
       <p:sp>
         <p:nvSpPr>
-          <p:cNvPr id="12" name="collect">
+          <p:cNvPr id="14" name="collect">
             <a:extLst xmlns:a="http://schemas.openxmlformats.org/drawingml/2006/main">
               <a:ext uri="{FF2B5EF4-FFF2-40B4-BE49-F238E27FC236}">
-                <a16:creationId xmlns:a16="http://schemas.microsoft.com/office/drawing/2014/main" id="{793D9487-BA7B-4A16-80B9-A5974C886197}"/>
+                <a16:creationId xmlns:a16="http://schemas.microsoft.com/office/drawing/2014/main" id="{DE05AA2A-BA43-40BA-855A-B100CBD24F27}"/>
               </a:ext>
             </a:extLst>
           </p:cNvPr>
@@ -1706,12 +1852,12 @@
         </p:nvSpPr>
         <p:spPr>
           <a:xfrm xmlns:a="http://schemas.openxmlformats.org/drawingml/2006/main">
-            <a:off x="6800850" y="1905000"/>
-            <a:ext cx="1762125" cy="685800"/>
+            <a:off x="8172450" y="1905000"/>
+            <a:ext cx="1333500" cy="742950"/>
           </a:xfrm>
           <a:prstGeom xmlns:a="http://schemas.openxmlformats.org/drawingml/2006/main" prst="roundRect">
             <a:avLst>
-              <a:gd name="adj" fmla="val 8333"/>
+              <a:gd name="adj" fmla="val 7692"/>
             </a:avLst>
           </a:prstGeom>
           <a:solidFill xmlns:a="http://schemas.openxmlformats.org/drawingml/2006/main">
@@ -1729,14 +1875,14 @@
           <a:lstStyle xmlns:a="http://schemas.openxmlformats.org/drawingml/2006/main"/>
           <a:p xmlns:a="http://schemas.openxmlformats.org/drawingml/2006/main">
             <a:pPr algn="ctr">
-              <a:defRPr sz="1050" b="1">
+              <a:defRPr sz="900" b="1">
                 <a:solidFill>
                   <a:srgbClr val="111111"/>
                 </a:solidFill>
               </a:defRPr>
             </a:pPr>
             <a:r>
-              <a:rPr sz="1050" b="1">
+              <a:rPr sz="900" b="1">
                 <a:solidFill>
                   <a:srgbClr val="111111"/>
                 </a:solidFill>
@@ -1746,14 +1892,14 @@
           </a:p>
           <a:p xmlns:a="http://schemas.openxmlformats.org/drawingml/2006/main">
             <a:pPr algn="ctr">
-              <a:defRPr sz="1050" b="1">
+              <a:defRPr sz="900" b="1">
                 <a:solidFill>
                   <a:srgbClr val="111111"/>
                 </a:solidFill>
               </a:defRPr>
             </a:pPr>
             <a:r>
-              <a:rPr sz="1050" b="1">
+              <a:rPr sz="900" b="1">
                 <a:solidFill>
                   <a:srgbClr val="111111"/>
                 </a:solidFill>
@@ -1765,10 +1911,10 @@
       </p:sp>
       <p:sp>
         <p:nvSpPr>
-          <p:cNvPr id="13" name="store">
+          <p:cNvPr id="15" name="store">
             <a:extLst xmlns:a="http://schemas.openxmlformats.org/drawingml/2006/main">
               <a:ext uri="{FF2B5EF4-FFF2-40B4-BE49-F238E27FC236}">
-                <a16:creationId xmlns:a16="http://schemas.microsoft.com/office/drawing/2014/main" id="{FABF3605-717A-40DC-A680-6CFBB0F0CC6D}"/>
+                <a16:creationId xmlns:a16="http://schemas.microsoft.com/office/drawing/2014/main" id="{81059A18-0B4A-4976-90CD-1FBEE74803D3}"/>
               </a:ext>
             </a:extLst>
           </p:cNvPr>
@@ -1779,12 +1925,12 @@
         </p:nvSpPr>
         <p:spPr>
           <a:xfrm xmlns:a="http://schemas.openxmlformats.org/drawingml/2006/main">
-            <a:off x="8963025" y="1905000"/>
-            <a:ext cx="1762125" cy="685800"/>
+            <a:off x="9677400" y="1905000"/>
+            <a:ext cx="1476375" cy="742950"/>
           </a:xfrm>
           <a:prstGeom xmlns:a="http://schemas.openxmlformats.org/drawingml/2006/main" prst="roundRect">
             <a:avLst>
-              <a:gd name="adj" fmla="val 8333"/>
+              <a:gd name="adj" fmla="val 7692"/>
             </a:avLst>
           </a:prstGeom>
           <a:solidFill xmlns:a="http://schemas.openxmlformats.org/drawingml/2006/main">
@@ -1802,14 +1948,14 @@
           <a:lstStyle xmlns:a="http://schemas.openxmlformats.org/drawingml/2006/main"/>
           <a:p xmlns:a="http://schemas.openxmlformats.org/drawingml/2006/main">
             <a:pPr algn="ctr">
-              <a:defRPr sz="1050" b="1">
+              <a:defRPr sz="900" b="1">
                 <a:solidFill>
                   <a:srgbClr val="111111"/>
                 </a:solidFill>
               </a:defRPr>
             </a:pPr>
             <a:r>
-              <a:rPr sz="1050" b="1">
+              <a:rPr sz="900" b="1">
                 <a:solidFill>
                   <a:srgbClr val="111111"/>
                 </a:solidFill>
@@ -1819,14 +1965,14 @@
           </a:p>
           <a:p xmlns:a="http://schemas.openxmlformats.org/drawingml/2006/main">
             <a:pPr algn="ctr">
-              <a:defRPr sz="1050" b="1">
+              <a:defRPr sz="900" b="1">
                 <a:solidFill>
                   <a:srgbClr val="111111"/>
                 </a:solidFill>
               </a:defRPr>
             </a:pPr>
             <a:r>
-              <a:rPr sz="1050" b="1">
+              <a:rPr sz="900" b="1">
                 <a:solidFill>
                   <a:srgbClr val="111111"/>
                 </a:solidFill>
@@ -1838,10 +1984,10 @@
       </p:sp>
       <p:sp>
         <p:nvSpPr>
-          <p:cNvPr id="14" name="upload-due">
+          <p:cNvPr id="16" name="upload-due">
             <a:extLst xmlns:a="http://schemas.openxmlformats.org/drawingml/2006/main">
               <a:ext uri="{FF2B5EF4-FFF2-40B4-BE49-F238E27FC236}">
-                <a16:creationId xmlns:a16="http://schemas.microsoft.com/office/drawing/2014/main" id="{E827F60B-5B3D-4E15-9130-433239F17654}"/>
+                <a16:creationId xmlns:a16="http://schemas.microsoft.com/office/drawing/2014/main" id="{1EA1E129-15C3-4E12-8678-F68BFB63E576}"/>
               </a:ext>
             </a:extLst>
           </p:cNvPr>
@@ -1852,7 +1998,7 @@
         </p:nvSpPr>
         <p:spPr>
           <a:xfrm xmlns:a="http://schemas.openxmlformats.org/drawingml/2006/main">
-            <a:off x="9077325" y="3238500"/>
+            <a:off x="9658350" y="3238500"/>
             <a:ext cx="1524000" cy="895350"/>
           </a:xfrm>
           <a:prstGeom xmlns:a="http://schemas.openxmlformats.org/drawingml/2006/main" prst="diamond">
@@ -1909,10 +2055,10 @@
       </p:sp>
       <p:sp>
         <p:nvSpPr>
-          <p:cNvPr id="15" name="transmit">
+          <p:cNvPr id="17" name="transmit">
             <a:extLst xmlns:a="http://schemas.openxmlformats.org/drawingml/2006/main">
               <a:ext uri="{FF2B5EF4-FFF2-40B4-BE49-F238E27FC236}">
-                <a16:creationId xmlns:a16="http://schemas.microsoft.com/office/drawing/2014/main" id="{4608907C-9DF5-4D32-B945-E8AE9EDB6075}"/>
+                <a16:creationId xmlns:a16="http://schemas.microsoft.com/office/drawing/2014/main" id="{F74DA6C5-14CC-42DA-A81C-F08EDE6BB57D}"/>
               </a:ext>
             </a:extLst>
           </p:cNvPr>
@@ -1923,7 +2069,7 @@
         </p:nvSpPr>
         <p:spPr>
           <a:xfrm xmlns:a="http://schemas.openxmlformats.org/drawingml/2006/main">
-            <a:off x="6800850" y="3343275"/>
+            <a:off x="7305675" y="3343275"/>
             <a:ext cx="1762125" cy="685800"/>
           </a:xfrm>
           <a:prstGeom xmlns:a="http://schemas.openxmlformats.org/drawingml/2006/main" prst="roundRect">
@@ -1982,10 +2128,10 @@
       </p:sp>
       <p:sp>
         <p:nvSpPr>
-          <p:cNvPr id="16" name="sleep">
+          <p:cNvPr id="18" name="sleep">
             <a:extLst xmlns:a="http://schemas.openxmlformats.org/drawingml/2006/main">
               <a:ext uri="{FF2B5EF4-FFF2-40B4-BE49-F238E27FC236}">
-                <a16:creationId xmlns:a16="http://schemas.microsoft.com/office/drawing/2014/main" id="{1D2D8CF0-C3F5-4C4A-AF83-75DD3CE326B4}"/>
+                <a16:creationId xmlns:a16="http://schemas.microsoft.com/office/drawing/2014/main" id="{8CBD03EC-43D3-452B-9985-9D8D4FA47080}"/>
               </a:ext>
             </a:extLst>
           </p:cNvPr>
@@ -1996,7 +2142,7 @@
         </p:nvSpPr>
         <p:spPr>
           <a:xfrm xmlns:a="http://schemas.openxmlformats.org/drawingml/2006/main">
-            <a:off x="9077325" y="4953000"/>
+            <a:off x="9534525" y="4953000"/>
             <a:ext cx="1762125" cy="685800"/>
           </a:xfrm>
           <a:prstGeom xmlns:a="http://schemas.openxmlformats.org/drawingml/2006/main" prst="roundRect">
@@ -2055,7 +2201,7 @@
       </p:sp>
       <p:cxnSp>
         <p:nvCxnSpPr>
-          <p:cNvPr id="47" name=""/>
+          <p:cNvPr id="53" name=""/>
           <p:cNvCxnSpPr>
             <a:stCxn xmlns:a="http://schemas.openxmlformats.org/drawingml/2006/main" id="9" idx="3"/>
             <a:endCxn xmlns:a="http://schemas.openxmlformats.org/drawingml/2006/main" id="10" idx="1"/>
@@ -2064,8 +2210,8 @@
         </p:nvCxnSpPr>
         <p:spPr>
           <a:xfrm xmlns:a="http://schemas.openxmlformats.org/drawingml/2006/main">
-            <a:off x="2362200" y="2247900"/>
-            <a:ext cx="400050" cy="0"/>
+            <a:off x="1981200" y="2276475"/>
+            <a:ext cx="171450" cy="0"/>
           </a:xfrm>
           <a:prstGeom xmlns:a="http://schemas.openxmlformats.org/drawingml/2006/main" prst="straightConnector1">
             <a:avLst/>
@@ -2073,162 +2219,6 @@
           <a:ln xmlns:a="http://schemas.openxmlformats.org/drawingml/2006/main" w="19050">
             <a:solidFill>
               <a:srgbClr val="548235"/>
-            </a:solidFill>
-            <a:prstDash val="solid"/>
-            <a:tailEnd type="arrow" w="med" len="med"/>
-          </a:ln>
-        </p:spPr>
-      </p:cxnSp>
-      <p:cxnSp>
-        <p:nvCxnSpPr>
-          <p:cNvPr id="48" name=""/>
-          <p:cNvCxnSpPr>
-            <a:stCxn xmlns:a="http://schemas.openxmlformats.org/drawingml/2006/main" id="10" idx="3"/>
-            <a:endCxn xmlns:a="http://schemas.openxmlformats.org/drawingml/2006/main" id="11" idx="1"/>
-          </p:cNvCxnSpPr>
-          <p:nvPr/>
-        </p:nvCxnSpPr>
-        <p:spPr>
-          <a:xfrm xmlns:a="http://schemas.openxmlformats.org/drawingml/2006/main">
-            <a:off x="4381500" y="2247900"/>
-            <a:ext cx="400050" cy="0"/>
-          </a:xfrm>
-          <a:prstGeom xmlns:a="http://schemas.openxmlformats.org/drawingml/2006/main" prst="straightConnector1">
-            <a:avLst/>
-          </a:prstGeom>
-          <a:ln xmlns:a="http://schemas.openxmlformats.org/drawingml/2006/main" w="19050">
-            <a:solidFill>
-              <a:srgbClr val="548235"/>
-            </a:solidFill>
-            <a:prstDash val="solid"/>
-            <a:tailEnd type="arrow" w="med" len="med"/>
-          </a:ln>
-        </p:spPr>
-      </p:cxnSp>
-      <p:cxnSp>
-        <p:nvCxnSpPr>
-          <p:cNvPr id="49" name=""/>
-          <p:cNvCxnSpPr>
-            <a:stCxn xmlns:a="http://schemas.openxmlformats.org/drawingml/2006/main" id="11" idx="3"/>
-            <a:endCxn xmlns:a="http://schemas.openxmlformats.org/drawingml/2006/main" id="12" idx="1"/>
-          </p:cNvCxnSpPr>
-          <p:nvPr/>
-        </p:nvCxnSpPr>
-        <p:spPr>
-          <a:xfrm xmlns:a="http://schemas.openxmlformats.org/drawingml/2006/main">
-            <a:off x="6400800" y="2247900"/>
-            <a:ext cx="400050" cy="0"/>
-          </a:xfrm>
-          <a:prstGeom xmlns:a="http://schemas.openxmlformats.org/drawingml/2006/main" prst="straightConnector1">
-            <a:avLst/>
-          </a:prstGeom>
-          <a:ln xmlns:a="http://schemas.openxmlformats.org/drawingml/2006/main" w="19050">
-            <a:solidFill>
-              <a:srgbClr val="5B5B5B"/>
-            </a:solidFill>
-            <a:prstDash val="solid"/>
-            <a:tailEnd type="arrow" w="med" len="med"/>
-          </a:ln>
-        </p:spPr>
-      </p:cxnSp>
-      <p:cxnSp>
-        <p:nvCxnSpPr>
-          <p:cNvPr id="50" name=""/>
-          <p:cNvCxnSpPr>
-            <a:stCxn xmlns:a="http://schemas.openxmlformats.org/drawingml/2006/main" id="12" idx="3"/>
-            <a:endCxn xmlns:a="http://schemas.openxmlformats.org/drawingml/2006/main" id="13" idx="1"/>
-          </p:cNvCxnSpPr>
-          <p:nvPr/>
-        </p:nvCxnSpPr>
-        <p:spPr>
-          <a:xfrm xmlns:a="http://schemas.openxmlformats.org/drawingml/2006/main">
-            <a:off x="8562975" y="2247900"/>
-            <a:ext cx="400050" cy="0"/>
-          </a:xfrm>
-          <a:prstGeom xmlns:a="http://schemas.openxmlformats.org/drawingml/2006/main" prst="straightConnector1">
-            <a:avLst/>
-          </a:prstGeom>
-          <a:ln xmlns:a="http://schemas.openxmlformats.org/drawingml/2006/main" w="19050">
-            <a:solidFill>
-              <a:srgbClr val="5B5B5B"/>
-            </a:solidFill>
-            <a:prstDash val="solid"/>
-            <a:tailEnd type="arrow" w="med" len="med"/>
-          </a:ln>
-        </p:spPr>
-      </p:cxnSp>
-      <p:cxnSp>
-        <p:nvCxnSpPr>
-          <p:cNvPr id="51" name=""/>
-          <p:cNvCxnSpPr>
-            <a:stCxn xmlns:a="http://schemas.openxmlformats.org/drawingml/2006/main" id="13" idx="2"/>
-            <a:endCxn xmlns:a="http://schemas.openxmlformats.org/drawingml/2006/main" id="14" idx="0"/>
-          </p:cNvCxnSpPr>
-          <p:nvPr/>
-        </p:nvCxnSpPr>
-        <p:spPr>
-          <a:xfrm xmlns:a="http://schemas.openxmlformats.org/drawingml/2006/main" flipH="1">
-            <a:off x="9839325" y="2590800"/>
-            <a:ext cx="4763" cy="647700"/>
-          </a:xfrm>
-          <a:prstGeom xmlns:a="http://schemas.openxmlformats.org/drawingml/2006/main" prst="straightConnector1">
-            <a:avLst/>
-          </a:prstGeom>
-          <a:ln xmlns:a="http://schemas.openxmlformats.org/drawingml/2006/main" w="19050">
-            <a:solidFill>
-              <a:srgbClr val="5B5B5B"/>
-            </a:solidFill>
-            <a:prstDash val="solid"/>
-            <a:tailEnd type="arrow" w="med" len="med"/>
-          </a:ln>
-        </p:spPr>
-      </p:cxnSp>
-      <p:cxnSp>
-        <p:nvCxnSpPr>
-          <p:cNvPr id="52" name=""/>
-          <p:cNvCxnSpPr>
-            <a:stCxn xmlns:a="http://schemas.openxmlformats.org/drawingml/2006/main" id="14" idx="1"/>
-            <a:endCxn xmlns:a="http://schemas.openxmlformats.org/drawingml/2006/main" id="15" idx="3"/>
-          </p:cNvCxnSpPr>
-          <p:nvPr/>
-        </p:nvCxnSpPr>
-        <p:spPr>
-          <a:xfrm xmlns:a="http://schemas.openxmlformats.org/drawingml/2006/main" flipH="1">
-            <a:off x="8562975" y="3686175"/>
-            <a:ext cx="514350" cy="0"/>
-          </a:xfrm>
-          <a:prstGeom xmlns:a="http://schemas.openxmlformats.org/drawingml/2006/main" prst="straightConnector1">
-            <a:avLst/>
-          </a:prstGeom>
-          <a:ln xmlns:a="http://schemas.openxmlformats.org/drawingml/2006/main" w="19050">
-            <a:solidFill>
-              <a:srgbClr val="5B5B5B"/>
-            </a:solidFill>
-            <a:prstDash val="solid"/>
-            <a:tailEnd type="arrow" w="med" len="med"/>
-          </a:ln>
-        </p:spPr>
-      </p:cxnSp>
-      <p:cxnSp>
-        <p:nvCxnSpPr>
-          <p:cNvPr id="53" name=""/>
-          <p:cNvCxnSpPr>
-            <a:stCxn xmlns:a="http://schemas.openxmlformats.org/drawingml/2006/main" id="14" idx="2"/>
-            <a:endCxn xmlns:a="http://schemas.openxmlformats.org/drawingml/2006/main" id="16" idx="0"/>
-          </p:cNvCxnSpPr>
-          <p:nvPr/>
-        </p:nvCxnSpPr>
-        <p:spPr>
-          <a:xfrm xmlns:a="http://schemas.openxmlformats.org/drawingml/2006/main">
-            <a:off x="9839325" y="4133850"/>
-            <a:ext cx="119063" cy="819150"/>
-          </a:xfrm>
-          <a:prstGeom xmlns:a="http://schemas.openxmlformats.org/drawingml/2006/main" prst="straightConnector1">
-            <a:avLst/>
-          </a:prstGeom>
-          <a:ln xmlns:a="http://schemas.openxmlformats.org/drawingml/2006/main" w="19050">
-            <a:solidFill>
-              <a:srgbClr val="5B5B5B"/>
             </a:solidFill>
             <a:prstDash val="solid"/>
             <a:tailEnd type="arrow" w="med" len="med"/>
@@ -2239,26 +2229,22 @@
         <p:nvCxnSpPr>
           <p:cNvPr id="54" name=""/>
           <p:cNvCxnSpPr>
-            <a:stCxn xmlns:a="http://schemas.openxmlformats.org/drawingml/2006/main" id="15" idx="2"/>
-            <a:endCxn xmlns:a="http://schemas.openxmlformats.org/drawingml/2006/main" id="16" idx="1"/>
+            <a:stCxn xmlns:a="http://schemas.openxmlformats.org/drawingml/2006/main" id="10" idx="3"/>
+            <a:endCxn xmlns:a="http://schemas.openxmlformats.org/drawingml/2006/main" id="11" idx="1"/>
           </p:cNvCxnSpPr>
           <p:nvPr/>
         </p:nvCxnSpPr>
         <p:spPr>
           <a:xfrm xmlns:a="http://schemas.openxmlformats.org/drawingml/2006/main">
-            <a:off x="7681913" y="4029075"/>
-            <a:ext cx="1395413" cy="1266825"/>
-          </a:xfrm>
-          <a:prstGeom xmlns:a="http://schemas.openxmlformats.org/drawingml/2006/main" prst="bentConnector5">
-            <a:avLst>
-              <a:gd name="adj1" fmla="val 0"/>
-              <a:gd name="adj2" fmla="val 18045"/>
-              <a:gd name="adj3" fmla="val 83618"/>
-            </a:avLst>
+            <a:off x="3486150" y="2276475"/>
+            <a:ext cx="171450" cy="0"/>
+          </a:xfrm>
+          <a:prstGeom xmlns:a="http://schemas.openxmlformats.org/drawingml/2006/main" prst="straightConnector1">
+            <a:avLst/>
           </a:prstGeom>
           <a:ln xmlns:a="http://schemas.openxmlformats.org/drawingml/2006/main" w="19050">
             <a:solidFill>
-              <a:srgbClr val="5B5B5B"/>
+              <a:srgbClr val="548235"/>
             </a:solidFill>
             <a:prstDash val="solid"/>
             <a:tailEnd type="arrow" w="med" len="med"/>
@@ -2269,15 +2255,227 @@
         <p:nvCxnSpPr>
           <p:cNvPr id="55" name=""/>
           <p:cNvCxnSpPr>
+            <a:stCxn xmlns:a="http://schemas.openxmlformats.org/drawingml/2006/main" id="11" idx="3"/>
+            <a:endCxn xmlns:a="http://schemas.openxmlformats.org/drawingml/2006/main" id="12" idx="1"/>
+          </p:cNvCxnSpPr>
+          <p:nvPr/>
+        </p:nvCxnSpPr>
+        <p:spPr>
+          <a:xfrm xmlns:a="http://schemas.openxmlformats.org/drawingml/2006/main">
+            <a:off x="4991100" y="2276475"/>
+            <a:ext cx="171450" cy="0"/>
+          </a:xfrm>
+          <a:prstGeom xmlns:a="http://schemas.openxmlformats.org/drawingml/2006/main" prst="straightConnector1">
+            <a:avLst/>
+          </a:prstGeom>
+          <a:ln xmlns:a="http://schemas.openxmlformats.org/drawingml/2006/main" w="19050">
+            <a:solidFill>
+              <a:srgbClr val="548235"/>
+            </a:solidFill>
+            <a:prstDash val="solid"/>
+            <a:tailEnd type="arrow" w="med" len="med"/>
+          </a:ln>
+        </p:spPr>
+      </p:cxnSp>
+      <p:cxnSp>
+        <p:nvCxnSpPr>
+          <p:cNvPr id="56" name=""/>
+          <p:cNvCxnSpPr>
+            <a:stCxn xmlns:a="http://schemas.openxmlformats.org/drawingml/2006/main" id="12" idx="3"/>
+            <a:endCxn xmlns:a="http://schemas.openxmlformats.org/drawingml/2006/main" id="13" idx="1"/>
+          </p:cNvCxnSpPr>
+          <p:nvPr/>
+        </p:nvCxnSpPr>
+        <p:spPr>
+          <a:xfrm xmlns:a="http://schemas.openxmlformats.org/drawingml/2006/main">
+            <a:off x="6496050" y="2276475"/>
+            <a:ext cx="171450" cy="0"/>
+          </a:xfrm>
+          <a:prstGeom xmlns:a="http://schemas.openxmlformats.org/drawingml/2006/main" prst="straightConnector1">
+            <a:avLst/>
+          </a:prstGeom>
+          <a:ln xmlns:a="http://schemas.openxmlformats.org/drawingml/2006/main" w="19050">
+            <a:solidFill>
+              <a:srgbClr val="548235"/>
+            </a:solidFill>
+            <a:prstDash val="solid"/>
+            <a:tailEnd type="arrow" w="med" len="med"/>
+          </a:ln>
+        </p:spPr>
+      </p:cxnSp>
+      <p:cxnSp>
+        <p:nvCxnSpPr>
+          <p:cNvPr id="57" name=""/>
+          <p:cNvCxnSpPr>
+            <a:stCxn xmlns:a="http://schemas.openxmlformats.org/drawingml/2006/main" id="13" idx="3"/>
+            <a:endCxn xmlns:a="http://schemas.openxmlformats.org/drawingml/2006/main" id="14" idx="1"/>
+          </p:cNvCxnSpPr>
+          <p:nvPr/>
+        </p:nvCxnSpPr>
+        <p:spPr>
+          <a:xfrm xmlns:a="http://schemas.openxmlformats.org/drawingml/2006/main">
+            <a:off x="8001000" y="2276475"/>
+            <a:ext cx="171450" cy="0"/>
+          </a:xfrm>
+          <a:prstGeom xmlns:a="http://schemas.openxmlformats.org/drawingml/2006/main" prst="straightConnector1">
+            <a:avLst/>
+          </a:prstGeom>
+          <a:ln xmlns:a="http://schemas.openxmlformats.org/drawingml/2006/main" w="19050">
+            <a:solidFill>
+              <a:srgbClr val="5B5B5B"/>
+            </a:solidFill>
+            <a:prstDash val="solid"/>
+            <a:tailEnd type="arrow" w="med" len="med"/>
+          </a:ln>
+        </p:spPr>
+      </p:cxnSp>
+      <p:cxnSp>
+        <p:nvCxnSpPr>
+          <p:cNvPr id="58" name=""/>
+          <p:cNvCxnSpPr>
+            <a:stCxn xmlns:a="http://schemas.openxmlformats.org/drawingml/2006/main" id="14" idx="3"/>
+            <a:endCxn xmlns:a="http://schemas.openxmlformats.org/drawingml/2006/main" id="15" idx="1"/>
+          </p:cNvCxnSpPr>
+          <p:nvPr/>
+        </p:nvCxnSpPr>
+        <p:spPr>
+          <a:xfrm xmlns:a="http://schemas.openxmlformats.org/drawingml/2006/main">
+            <a:off x="9505950" y="2276475"/>
+            <a:ext cx="171450" cy="0"/>
+          </a:xfrm>
+          <a:prstGeom xmlns:a="http://schemas.openxmlformats.org/drawingml/2006/main" prst="straightConnector1">
+            <a:avLst/>
+          </a:prstGeom>
+          <a:ln xmlns:a="http://schemas.openxmlformats.org/drawingml/2006/main" w="19050">
+            <a:solidFill>
+              <a:srgbClr val="5B5B5B"/>
+            </a:solidFill>
+            <a:prstDash val="solid"/>
+            <a:tailEnd type="arrow" w="med" len="med"/>
+          </a:ln>
+        </p:spPr>
+      </p:cxnSp>
+      <p:cxnSp>
+        <p:nvCxnSpPr>
+          <p:cNvPr id="59" name=""/>
+          <p:cNvCxnSpPr>
+            <a:stCxn xmlns:a="http://schemas.openxmlformats.org/drawingml/2006/main" id="15" idx="2"/>
+            <a:endCxn xmlns:a="http://schemas.openxmlformats.org/drawingml/2006/main" id="16" idx="0"/>
+          </p:cNvCxnSpPr>
+          <p:nvPr/>
+        </p:nvCxnSpPr>
+        <p:spPr>
+          <a:xfrm xmlns:a="http://schemas.openxmlformats.org/drawingml/2006/main">
+            <a:off x="10415588" y="2647950"/>
+            <a:ext cx="4763" cy="590550"/>
+          </a:xfrm>
+          <a:prstGeom xmlns:a="http://schemas.openxmlformats.org/drawingml/2006/main" prst="straightConnector1">
+            <a:avLst/>
+          </a:prstGeom>
+          <a:ln xmlns:a="http://schemas.openxmlformats.org/drawingml/2006/main" w="19050">
+            <a:solidFill>
+              <a:srgbClr val="5B5B5B"/>
+            </a:solidFill>
+            <a:prstDash val="solid"/>
+            <a:tailEnd type="arrow" w="med" len="med"/>
+          </a:ln>
+        </p:spPr>
+      </p:cxnSp>
+      <p:cxnSp>
+        <p:nvCxnSpPr>
+          <p:cNvPr id="60" name=""/>
+          <p:cNvCxnSpPr>
+            <a:stCxn xmlns:a="http://schemas.openxmlformats.org/drawingml/2006/main" id="16" idx="1"/>
+            <a:endCxn xmlns:a="http://schemas.openxmlformats.org/drawingml/2006/main" id="17" idx="3"/>
+          </p:cNvCxnSpPr>
+          <p:nvPr/>
+        </p:nvCxnSpPr>
+        <p:spPr>
+          <a:xfrm xmlns:a="http://schemas.openxmlformats.org/drawingml/2006/main" flipH="1">
+            <a:off x="9067800" y="3686175"/>
+            <a:ext cx="590550" cy="0"/>
+          </a:xfrm>
+          <a:prstGeom xmlns:a="http://schemas.openxmlformats.org/drawingml/2006/main" prst="straightConnector1">
+            <a:avLst/>
+          </a:prstGeom>
+          <a:ln xmlns:a="http://schemas.openxmlformats.org/drawingml/2006/main" w="19050">
+            <a:solidFill>
+              <a:srgbClr val="5B5B5B"/>
+            </a:solidFill>
+            <a:prstDash val="solid"/>
+            <a:tailEnd type="arrow" w="med" len="med"/>
+          </a:ln>
+        </p:spPr>
+      </p:cxnSp>
+      <p:cxnSp>
+        <p:nvCxnSpPr>
+          <p:cNvPr id="61" name=""/>
+          <p:cNvCxnSpPr>
             <a:stCxn xmlns:a="http://schemas.openxmlformats.org/drawingml/2006/main" id="16" idx="2"/>
-            <a:endCxn xmlns:a="http://schemas.openxmlformats.org/drawingml/2006/main" id="11" idx="2"/>
+            <a:endCxn xmlns:a="http://schemas.openxmlformats.org/drawingml/2006/main" id="18" idx="0"/>
           </p:cNvCxnSpPr>
           <p:nvPr/>
         </p:nvCxnSpPr>
         <p:spPr>
+          <a:xfrm xmlns:a="http://schemas.openxmlformats.org/drawingml/2006/main" flipH="1">
+            <a:off x="10415588" y="4133850"/>
+            <a:ext cx="4763" cy="819150"/>
+          </a:xfrm>
+          <a:prstGeom xmlns:a="http://schemas.openxmlformats.org/drawingml/2006/main" prst="straightConnector1">
+            <a:avLst/>
+          </a:prstGeom>
+          <a:ln xmlns:a="http://schemas.openxmlformats.org/drawingml/2006/main" w="19050">
+            <a:solidFill>
+              <a:srgbClr val="5B5B5B"/>
+            </a:solidFill>
+            <a:prstDash val="solid"/>
+            <a:tailEnd type="arrow" w="med" len="med"/>
+          </a:ln>
+        </p:spPr>
+      </p:cxnSp>
+      <p:cxnSp>
+        <p:nvCxnSpPr>
+          <p:cNvPr id="62" name=""/>
+          <p:cNvCxnSpPr>
+            <a:stCxn xmlns:a="http://schemas.openxmlformats.org/drawingml/2006/main" id="17" idx="2"/>
+            <a:endCxn xmlns:a="http://schemas.openxmlformats.org/drawingml/2006/main" id="18" idx="1"/>
+          </p:cNvCxnSpPr>
+          <p:nvPr/>
+        </p:nvCxnSpPr>
+        <p:spPr>
+          <a:xfrm xmlns:a="http://schemas.openxmlformats.org/drawingml/2006/main">
+            <a:off x="8186738" y="4029075"/>
+            <a:ext cx="1347788" cy="1266825"/>
+          </a:xfrm>
+          <a:prstGeom xmlns:a="http://schemas.openxmlformats.org/drawingml/2006/main" prst="bentConnector5">
+            <a:avLst>
+              <a:gd name="adj1" fmla="val 0"/>
+              <a:gd name="adj2" fmla="val 18045"/>
+              <a:gd name="adj3" fmla="val 83039"/>
+            </a:avLst>
+          </a:prstGeom>
+          <a:ln xmlns:a="http://schemas.openxmlformats.org/drawingml/2006/main" w="19050">
+            <a:solidFill>
+              <a:srgbClr val="5B5B5B"/>
+            </a:solidFill>
+            <a:prstDash val="solid"/>
+            <a:tailEnd type="arrow" w="med" len="med"/>
+          </a:ln>
+        </p:spPr>
+      </p:cxnSp>
+      <p:cxnSp>
+        <p:nvCxnSpPr>
+          <p:cNvPr id="63" name=""/>
+          <p:cNvCxnSpPr>
+            <a:stCxn xmlns:a="http://schemas.openxmlformats.org/drawingml/2006/main" id="18" idx="2"/>
+            <a:endCxn xmlns:a="http://schemas.openxmlformats.org/drawingml/2006/main" id="13" idx="2"/>
+          </p:cNvCxnSpPr>
+          <p:nvPr/>
+        </p:nvCxnSpPr>
+        <p:spPr>
           <a:xfrm xmlns:a="http://schemas.openxmlformats.org/drawingml/2006/main" flipH="1" flipV="1">
-            <a:off x="5591175" y="2590800"/>
-            <a:ext cx="4367213" cy="3276600"/>
+            <a:off x="7334250" y="2647950"/>
+            <a:ext cx="4181475" cy="3219450"/>
           </a:xfrm>
           <a:prstGeom xmlns:a="http://schemas.openxmlformats.org/drawingml/2006/main" prst="bentConnector4">
             <a:avLst/>
@@ -2293,10 +2491,10 @@
       </p:cxnSp>
       <p:sp>
         <p:nvSpPr>
-          <p:cNvPr id="26" name="few-days-label">
+          <p:cNvPr id="30" name="few-days-label">
             <a:extLst xmlns:a="http://schemas.openxmlformats.org/drawingml/2006/main">
               <a:ext uri="{FF2B5EF4-FFF2-40B4-BE49-F238E27FC236}">
-                <a16:creationId xmlns:a16="http://schemas.microsoft.com/office/drawing/2014/main" id="{EA1D8A8B-1E43-403F-B72E-F5508785A234}"/>
+                <a16:creationId xmlns:a16="http://schemas.microsoft.com/office/drawing/2014/main" id="{CA1B49AC-88C6-4949-9897-EA3684B50E34}"/>
               </a:ext>
             </a:extLst>
           </p:cNvPr>
@@ -2307,7 +2505,7 @@
         </p:nvSpPr>
         <p:spPr>
           <a:xfrm xmlns:a="http://schemas.openxmlformats.org/drawingml/2006/main">
-            <a:off x="8858250" y="2905125"/>
+            <a:off x="9401175" y="2905125"/>
             <a:ext cx="2000250" cy="228600"/>
           </a:xfrm>
           <a:prstGeom xmlns:a="http://schemas.openxmlformats.org/drawingml/2006/main" prst="rect">
@@ -2343,10 +2541,10 @@
       </p:sp>
       <p:sp>
         <p:nvSpPr>
-          <p:cNvPr id="27" name="yes-label">
+          <p:cNvPr id="31" name="yes-label">
             <a:extLst xmlns:a="http://schemas.openxmlformats.org/drawingml/2006/main">
               <a:ext uri="{FF2B5EF4-FFF2-40B4-BE49-F238E27FC236}">
-                <a16:creationId xmlns:a16="http://schemas.microsoft.com/office/drawing/2014/main" id="{AE5ADFCC-978D-409D-AAB9-72D610162094}"/>
+                <a16:creationId xmlns:a16="http://schemas.microsoft.com/office/drawing/2014/main" id="{BE9B7622-8746-4ED3-A528-D17394E72AD6}"/>
               </a:ext>
             </a:extLst>
           </p:cNvPr>
@@ -2357,7 +2555,7 @@
         </p:nvSpPr>
         <p:spPr>
           <a:xfrm xmlns:a="http://schemas.openxmlformats.org/drawingml/2006/main">
-            <a:off x="8601075" y="3362325"/>
+            <a:off x="9124950" y="3362325"/>
             <a:ext cx="419100" cy="209550"/>
           </a:xfrm>
           <a:prstGeom xmlns:a="http://schemas.openxmlformats.org/drawingml/2006/main" prst="rect">
@@ -2393,10 +2591,10 @@
       </p:sp>
       <p:sp>
         <p:nvSpPr>
-          <p:cNvPr id="28" name="no-label">
+          <p:cNvPr id="32" name="no-label">
             <a:extLst xmlns:a="http://schemas.openxmlformats.org/drawingml/2006/main">
               <a:ext uri="{FF2B5EF4-FFF2-40B4-BE49-F238E27FC236}">
-                <a16:creationId xmlns:a16="http://schemas.microsoft.com/office/drawing/2014/main" id="{22F33C39-15D0-4F0A-A38F-7F312E498453}"/>
+                <a16:creationId xmlns:a16="http://schemas.microsoft.com/office/drawing/2014/main" id="{D99DC726-FC00-40BB-8CC3-F8FBF553CDB4}"/>
               </a:ext>
             </a:extLst>
           </p:cNvPr>
@@ -2407,7 +2605,7 @@
         </p:nvSpPr>
         <p:spPr>
           <a:xfrm xmlns:a="http://schemas.openxmlformats.org/drawingml/2006/main">
-            <a:off x="9753600" y="4305300"/>
+            <a:off x="10306050" y="4305300"/>
             <a:ext cx="419100" cy="209550"/>
           </a:xfrm>
           <a:prstGeom xmlns:a="http://schemas.openxmlformats.org/drawingml/2006/main" prst="rect">
@@ -2443,10 +2641,10 @@
       </p:sp>
       <p:sp>
         <p:nvSpPr>
-          <p:cNvPr id="29" name="loop-label">
+          <p:cNvPr id="33" name="loop-label">
             <a:extLst xmlns:a="http://schemas.openxmlformats.org/drawingml/2006/main">
               <a:ext uri="{FF2B5EF4-FFF2-40B4-BE49-F238E27FC236}">
-                <a16:creationId xmlns:a16="http://schemas.microsoft.com/office/drawing/2014/main" id="{08553A1C-042B-4BBA-A39B-A5086C3283D8}"/>
+                <a16:creationId xmlns:a16="http://schemas.microsoft.com/office/drawing/2014/main" id="{F60CB347-496C-4213-BDF1-9806BD0CF868}"/>
               </a:ext>
             </a:extLst>
           </p:cNvPr>
@@ -2457,7 +2655,7 @@
         </p:nvSpPr>
         <p:spPr>
           <a:xfrm xmlns:a="http://schemas.openxmlformats.org/drawingml/2006/main">
-            <a:off x="5238750" y="5810250"/>
+            <a:off x="5810250" y="5810250"/>
             <a:ext cx="2857500" cy="247650"/>
           </a:xfrm>
           <a:prstGeom xmlns:a="http://schemas.openxmlformats.org/drawingml/2006/main" prst="rect">
@@ -2493,10 +2691,10 @@
       </p:sp>
       <p:sp>
         <p:nvSpPr>
-          <p:cNvPr id="30" name="summary-callout">
+          <p:cNvPr id="34" name="summary-callout">
             <a:extLst xmlns:a="http://schemas.openxmlformats.org/drawingml/2006/main">
               <a:ext uri="{FF2B5EF4-FFF2-40B4-BE49-F238E27FC236}">
-                <a16:creationId xmlns:a16="http://schemas.microsoft.com/office/drawing/2014/main" id="{D81CDB97-530B-4BFA-AF76-7910111A95F5}"/>
+                <a16:creationId xmlns:a16="http://schemas.microsoft.com/office/drawing/2014/main" id="{3DB291B7-93FD-4997-91FC-2691D0C6990F}"/>
               </a:ext>
             </a:extLst>
           </p:cNvPr>
@@ -2550,7 +2748,7 @@
     </p:spTree>
     <p:extLst>
       <p:ext uri="{BB962C8B-B14F-4D97-AF65-F5344CB8AC3E}">
-        <p14:creationId xmlns:p14="http://schemas.microsoft.com/office/powerpoint/2010/main" val="1683222956"/>
+        <p14:creationId xmlns:p14="http://schemas.microsoft.com/office/powerpoint/2010/main" val="631797040"/>
       </p:ext>
     </p:extLst>
   </p:cSld>

</xml_diff>